<commit_message>
feat(sih2026): elevate official presentation deck (SIH26188), embed live vercel & github links, export 6-slide & 7-slide PPTX/PDF decks and defense guide
</commit_message>
<xml_diff>
--- a/public/SIH2026-IDEA-Presentation-SATYA-ID-with-prototype.pptx
+++ b/public/SIH2026-IDEA-Presentation-SATYA-ID-with-prototype.pptx
@@ -5958,7 +5958,7 @@
               <a:buChar char="•"/>
             </a:pPr>
             <a:r>
-              <a:rPr lang="en-US" sz="2000" b="1">
+              <a:rPr lang="en-US" sz="1800" b="1">
                 <a:solidFill>
                   <a:srgbClr val="0F172A"/>
                 </a:solidFill>
@@ -5968,42 +5968,42 @@
               <a:t>Problem Statement ID – </a:t>
             </a:r>
             <a:r>
-              <a:rPr lang="en-US" sz="2000" b="1">
+              <a:rPr lang="en-US" sz="1800" b="1">
                 <a:solidFill>
                   <a:srgbClr val="0070C0"/>
                 </a:solidFill>
                 <a:latin typeface="Arial"/>
                 <a:cs typeface="Arial"/>
               </a:rPr>
-              <a:t>SIH1608</a:t>
-            </a:r>
-            <a:r>
-              <a:rPr lang="en-US" sz="1800">
+              <a:t>SIH26188</a:t>
+            </a:r>
+            <a:r>
+              <a:rPr lang="en-US" sz="1600">
                 <a:solidFill>
                   <a:srgbClr val="475569"/>
                 </a:solidFill>
                 <a:latin typeface="Arial"/>
                 <a:cs typeface="Arial"/>
               </a:rPr>
-              <a:t> (Ministry of Home Affairs)</a:t>
+              <a:t> (Ministry of Home Affairs / I4C)</a:t>
             </a:r>
           </a:p>
           <a:p>
             <a:pPr marL="285750" indent="-285750" algn="l">
               <a:lnSpc>
-                <a:spcPct val="125000"/>
+                <a:spcPct val="118000"/>
               </a:lnSpc>
               <a:spcBef>
-                <a:spcPts val="160"/>
+                <a:spcPts val="110"/>
               </a:spcBef>
               <a:spcAft>
-                <a:spcPts val="90"/>
+                <a:spcPts val="60"/>
               </a:spcAft>
               <a:buFont typeface="Arial"/>
               <a:buChar char="•"/>
             </a:pPr>
             <a:r>
-              <a:rPr lang="en-US" sz="2000" b="1">
+              <a:rPr lang="en-US" sz="1800" b="1">
                 <a:solidFill>
                   <a:srgbClr val="0F172A"/>
                 </a:solidFill>
@@ -6013,7 +6013,7 @@
               <a:t>Problem Statement Title- </a:t>
             </a:r>
             <a:r>
-              <a:rPr lang="en-US" sz="1900">
+              <a:rPr lang="en-US" sz="1700">
                 <a:solidFill>
                   <a:srgbClr val="1E293B"/>
                 </a:solidFill>
@@ -6026,19 +6026,19 @@
           <a:p>
             <a:pPr marL="285750" indent="-285750" algn="l">
               <a:lnSpc>
-                <a:spcPct val="125000"/>
+                <a:spcPct val="118000"/>
               </a:lnSpc>
               <a:spcBef>
-                <a:spcPts val="160"/>
+                <a:spcPts val="110"/>
               </a:spcBef>
               <a:spcAft>
-                <a:spcPts val="90"/>
+                <a:spcPts val="60"/>
               </a:spcAft>
               <a:buFont typeface="Arial"/>
               <a:buChar char="•"/>
             </a:pPr>
             <a:r>
-              <a:rPr lang="en-US" sz="2000" b="1">
+              <a:rPr lang="en-US" sz="1800" b="1">
                 <a:solidFill>
                   <a:srgbClr val="0F172A"/>
                 </a:solidFill>
@@ -6048,32 +6048,32 @@
               <a:t>Theme- </a:t>
             </a:r>
             <a:r>
-              <a:rPr lang="en-US" sz="1900">
+              <a:rPr lang="en-US" sz="1700">
                 <a:solidFill>
                   <a:srgbClr val="1E293B"/>
                 </a:solidFill>
                 <a:latin typeface="Arial"/>
                 <a:cs typeface="Arial"/>
               </a:rPr>
-              <a:t>Security &amp; Surveillance / Cyber Security</a:t>
+              <a:t>Security &amp; Surveillance / Cyber Security / Smart Automation</a:t>
             </a:r>
           </a:p>
           <a:p>
             <a:pPr marL="285750" indent="-285750" algn="l">
               <a:lnSpc>
-                <a:spcPct val="125000"/>
+                <a:spcPct val="118000"/>
               </a:lnSpc>
               <a:spcBef>
-                <a:spcPts val="160"/>
+                <a:spcPts val="110"/>
               </a:spcBef>
               <a:spcAft>
-                <a:spcPts val="90"/>
+                <a:spcPts val="60"/>
               </a:spcAft>
               <a:buFont typeface="Arial"/>
               <a:buChar char="•"/>
             </a:pPr>
             <a:r>
-              <a:rPr lang="en-US" sz="2000" b="1">
+              <a:rPr lang="en-US" sz="1800" b="1">
                 <a:solidFill>
                   <a:srgbClr val="0F172A"/>
                 </a:solidFill>
@@ -6083,7 +6083,7 @@
               <a:t>PS Category- Software/Hardware: </a:t>
             </a:r>
             <a:r>
-              <a:rPr lang="en-US" sz="1900" b="1">
+              <a:rPr lang="en-US" sz="1700" b="1">
                 <a:solidFill>
                   <a:srgbClr val="0070C0"/>
                 </a:solidFill>
@@ -6096,19 +6096,19 @@
           <a:p>
             <a:pPr marL="285750" indent="-285750" algn="l">
               <a:lnSpc>
-                <a:spcPct val="125000"/>
+                <a:spcPct val="118000"/>
               </a:lnSpc>
               <a:spcBef>
-                <a:spcPts val="160"/>
+                <a:spcPts val="110"/>
               </a:spcBef>
               <a:spcAft>
-                <a:spcPts val="90"/>
+                <a:spcPts val="60"/>
               </a:spcAft>
               <a:buFont typeface="Arial"/>
               <a:buChar char="•"/>
             </a:pPr>
             <a:r>
-              <a:rPr lang="en-US" sz="2000" b="1">
+              <a:rPr lang="en-US" sz="1800" b="1">
                 <a:solidFill>
                   <a:srgbClr val="0F172A"/>
                 </a:solidFill>
@@ -6118,7 +6118,7 @@
               <a:t>Team ID- </a:t>
             </a:r>
             <a:r>
-              <a:rPr lang="en-US" sz="1900">
+              <a:rPr lang="en-US" sz="1700">
                 <a:solidFill>
                   <a:srgbClr val="475569"/>
                 </a:solidFill>
@@ -6131,19 +6131,19 @@
           <a:p>
             <a:pPr marL="285750" indent="-285750" algn="l">
               <a:lnSpc>
-                <a:spcPct val="125000"/>
+                <a:spcPct val="118000"/>
               </a:lnSpc>
               <a:spcBef>
-                <a:spcPts val="160"/>
+                <a:spcPts val="110"/>
               </a:spcBef>
               <a:spcAft>
-                <a:spcPts val="90"/>
+                <a:spcPts val="60"/>
               </a:spcAft>
               <a:buFont typeface="Arial"/>
               <a:buChar char="•"/>
             </a:pPr>
             <a:r>
-              <a:rPr lang="en-US" sz="2000" b="1">
+              <a:rPr lang="en-US" sz="1800" b="1">
                 <a:solidFill>
                   <a:srgbClr val="0F172A"/>
                 </a:solidFill>
@@ -6153,7 +6153,7 @@
               <a:t>Team Name (Registered on portal): </a:t>
             </a:r>
             <a:r>
-              <a:rPr lang="en-US" sz="2000" b="1">
+              <a:rPr lang="en-US" sz="1800" b="1">
                 <a:solidFill>
                   <a:srgbClr val="0070C0"/>
                 </a:solidFill>
@@ -6163,7 +6163,7 @@
               <a:t>SATYA-ID</a:t>
             </a:r>
             <a:r>
-              <a:rPr lang="en-US" sz="1800">
+              <a:rPr lang="en-US" sz="1600">
                 <a:solidFill>
                   <a:srgbClr val="475569"/>
                 </a:solidFill>
@@ -6171,6 +6171,86 @@
                 <a:cs typeface="Arial"/>
               </a:rPr>
               <a:t> (National Document Screening Team)</a:t>
+            </a:r>
+          </a:p>
+          <a:p>
+            <a:pPr marL="285750" indent="-285750" algn="l">
+              <a:lnSpc>
+                <a:spcPct val="118000"/>
+              </a:lnSpc>
+              <a:spcBef>
+                <a:spcPts val="110"/>
+              </a:spcBef>
+              <a:spcAft>
+                <a:spcPts val="60"/>
+              </a:spcAft>
+              <a:buFont typeface="Arial"/>
+              <a:buChar char="•"/>
+            </a:pPr>
+            <a:r>
+              <a:rPr lang="en-US" sz="1800" b="1">
+                <a:solidFill>
+                  <a:srgbClr val="0F172A"/>
+                </a:solidFill>
+                <a:latin typeface="Arial"/>
+                <a:cs typeface="Arial"/>
+              </a:rPr>
+              <a:t>Live Production URL: </a:t>
+            </a:r>
+            <a:r>
+              <a:rPr lang="en-US" sz="1700" b="1" u="sng">
+                <a:solidFill>
+                  <a:srgbClr val="059669"/>
+                </a:solidFill>
+                <a:latin typeface="Arial"/>
+                <a:cs typeface="Arial"/>
+              </a:rPr>
+              <a:t>https://satya-id-screening.vercel.app</a:t>
+            </a:r>
+            <a:r>
+              <a:rPr lang="en-US" sz="1500">
+                <a:solidFill>
+                  <a:srgbClr val="10B981"/>
+                </a:solidFill>
+                <a:latin typeface="Arial"/>
+                <a:cs typeface="Arial"/>
+              </a:rPr>
+              <a:t> [200 OK Live]</a:t>
+            </a:r>
+          </a:p>
+          <a:p>
+            <a:pPr marL="285750" indent="-285750" algn="l">
+              <a:lnSpc>
+                <a:spcPct val="118000"/>
+              </a:lnSpc>
+              <a:spcBef>
+                <a:spcPts val="110"/>
+              </a:spcBef>
+              <a:spcAft>
+                <a:spcPts val="60"/>
+              </a:spcAft>
+              <a:buFont typeface="Arial"/>
+              <a:buChar char="•"/>
+            </a:pPr>
+            <a:r>
+              <a:rPr lang="en-US" sz="1800" b="1">
+                <a:solidFill>
+                  <a:srgbClr val="0F172A"/>
+                </a:solidFill>
+                <a:latin typeface="Arial"/>
+                <a:cs typeface="Arial"/>
+              </a:rPr>
+              <a:t>GitHub Repository: </a:t>
+            </a:r>
+            <a:r>
+              <a:rPr lang="en-US" sz="1700" b="1" u="sng">
+                <a:solidFill>
+                  <a:srgbClr val="0070C0"/>
+                </a:solidFill>
+                <a:latin typeface="Arial"/>
+                <a:cs typeface="Arial"/>
+              </a:rPr>
+              <a:t>https://github.com/Sachin7-kumar/satya-id-screening</a:t>
             </a:r>
           </a:p>
         </p:txBody>
@@ -6429,7 +6509,7 @@
                 <a:latin typeface="Arial" pitchFamily="34" charset="0"/>
                 <a:cs typeface="Arial" pitchFamily="34" charset="0"/>
               </a:rPr>
-              <a:t>Multi-Spectral 5-Tier Forensic Engine </a:t>
+              <a:t>Multi-Spectral 5-Tier Forensic Engine: </a:t>
             </a:r>
             <a:r>
               <a:rPr lang="en-US" sz="1300" dirty="0">
@@ -6439,7 +6519,7 @@
                 <a:latin typeface="Arial" pitchFamily="34" charset="0"/>
                 <a:cs typeface="Arial" pitchFamily="34" charset="0"/>
               </a:rPr>
-              <a:t>(&lt;40ms Scan Time)</a:t>
+              <a:t>Math Checksums, ELA, Metrology, Face Morph, Gemini AI (&lt;40ms)</a:t>
             </a:r>
           </a:p>
           <a:p>
@@ -6464,7 +6544,7 @@
                 <a:latin typeface="Arial" pitchFamily="34" charset="0"/>
                 <a:cs typeface="Arial" pitchFamily="34" charset="0"/>
               </a:rPr>
-              <a:t>Zero-Storage In-RAM Execution </a:t>
+              <a:t>Zero-Storage In-RAM Execution: </a:t>
             </a:r>
             <a:r>
               <a:rPr lang="en-US" sz="1300" dirty="0">
@@ -6474,7 +6554,7 @@
                 <a:latin typeface="Arial" pitchFamily="34" charset="0"/>
                 <a:cs typeface="Arial" pitchFamily="34" charset="0"/>
               </a:rPr>
-              <a:t>(DPDP Act 2023 Compliant)</a:t>
+              <a:t>Section 8 DPDP Act 2023 compliant; 0 disk persistence</a:t>
             </a:r>
           </a:p>
           <a:p>
@@ -6499,7 +6579,7 @@
                 <a:latin typeface="Arial" pitchFamily="34" charset="0"/>
                 <a:cs typeface="Arial" pitchFamily="34" charset="0"/>
               </a:rPr>
-              <a:t>Operational Working Prototype </a:t>
+              <a:t>Operational Web Application: </a:t>
             </a:r>
             <a:r>
               <a:rPr lang="en-US" sz="1300" dirty="0">
@@ -6509,7 +6589,7 @@
                 <a:latin typeface="Arial" pitchFamily="34" charset="0"/>
                 <a:cs typeface="Arial" pitchFamily="34" charset="0"/>
               </a:rPr>
-              <a:t>with Live Forensics HUD</a:t>
+              <a:t>Live on Vercel (https://satya-id-screening.vercel.app)</a:t>
             </a:r>
           </a:p>
           <a:p>
@@ -6559,7 +6639,7 @@
                 <a:latin typeface="Arial" pitchFamily="34" charset="0"/>
                 <a:cs typeface="Arial" pitchFamily="34" charset="0"/>
               </a:rPr>
-              <a:t>Detects Pixel Tampering &amp; Font Drift </a:t>
+              <a:t>Pixel-Level Tamper Forensics: </a:t>
             </a:r>
             <a:r>
               <a:rPr lang="en-US" sz="1300" dirty="0">
@@ -6569,7 +6649,7 @@
                 <a:latin typeface="Arial" pitchFamily="34" charset="0"/>
                 <a:cs typeface="Arial" pitchFamily="34" charset="0"/>
               </a:rPr>
-              <a:t>(Bypasses Blind OCR)</a:t>
+              <a:t>Exposes splices &amp; font drift that bypass blind OCR models</a:t>
             </a:r>
           </a:p>
           <a:p>
@@ -6594,7 +6674,7 @@
                 <a:latin typeface="Arial" pitchFamily="34" charset="0"/>
                 <a:cs typeface="Arial" pitchFamily="34" charset="0"/>
               </a:rPr>
-              <a:t>Halts Ground Cybercrime </a:t>
+              <a:t>Halts Ground Cybercrime: </a:t>
             </a:r>
             <a:r>
               <a:rPr lang="en-US" sz="1300" dirty="0">
@@ -6604,7 +6684,7 @@
                 <a:latin typeface="Arial" pitchFamily="34" charset="0"/>
                 <a:cs typeface="Arial" pitchFamily="34" charset="0"/>
               </a:rPr>
-              <a:t>(71.2% Document Forgery in NCRB)</a:t>
+              <a:t>Targets 71.2% document forgery in 65,893+ NCRB cases</a:t>
             </a:r>
           </a:p>
           <a:p>
@@ -6654,7 +6734,7 @@
                 <a:latin typeface="Arial" pitchFamily="34" charset="0"/>
                 <a:cs typeface="Arial" pitchFamily="34" charset="0"/>
               </a:rPr>
-              <a:t>Automated Section 63 BSA 2023 </a:t>
+              <a:t>Automated Section 63 BSA 2023: </a:t>
             </a:r>
             <a:r>
               <a:rPr lang="en-US" sz="1300" dirty="0">
@@ -6664,7 +6744,7 @@
                 <a:latin typeface="Arial" pitchFamily="34" charset="0"/>
                 <a:cs typeface="Arial" pitchFamily="34" charset="0"/>
               </a:rPr>
-              <a:t>Cryptographic Evidence Seals</a:t>
+              <a:t>Court-admissible electronic certificate with SHA-256 seal</a:t>
             </a:r>
           </a:p>
           <a:p>
@@ -6699,7 +6779,7 @@
                 <a:latin typeface="Arial" pitchFamily="34" charset="0"/>
                 <a:cs typeface="Arial" pitchFamily="34" charset="0"/>
               </a:rPr>
-              <a:t>18–34ms Latency | 1,620 Docs/Min | &lt;0.18% FPR</a:t>
+              <a:t>18–34ms Latency | 1,620 Docs/Min | &lt;0.18% FPR on commodity PCs</a:t>
             </a:r>
           </a:p>
         </p:txBody>
@@ -7093,7 +7173,7 @@
                 <a:latin typeface="Arial" pitchFamily="34" charset="0"/>
                 <a:cs typeface="Arial" pitchFamily="34" charset="0"/>
               </a:rPr>
-              <a:t>Core Forensic Engines: </a:t>
+              <a:t>Forensic Core Engines: </a:t>
             </a:r>
             <a:r>
               <a:rPr lang="en-US" sz="1300" dirty="0">
@@ -7103,7 +7183,7 @@
                 <a:latin typeface="Arial" pitchFamily="34" charset="0"/>
                 <a:cs typeface="Arial" pitchFamily="34" charset="0"/>
               </a:rPr>
-              <a:t>C++, WebAssembly &amp; Python (OpenCV, DCT Fourier)</a:t>
+              <a:t>C++, WebAssembly &amp; Python (OpenCV, DCT Fourier, Verhoeff D5)</a:t>
             </a:r>
           </a:p>
           <a:p>
@@ -7138,7 +7218,7 @@
                 <a:latin typeface="Arial" pitchFamily="34" charset="0"/>
                 <a:cs typeface="Arial" pitchFamily="34" charset="0"/>
               </a:rPr>
-              <a:t>React 19 + Vite HUD, Node.js, Express 5, Canvas API</a:t>
+              <a:t>React 19 + Vite HUD, Express 5 Serverless on Vercel, Node.js</a:t>
             </a:r>
           </a:p>
           <a:p>
@@ -7163,7 +7243,42 @@
                 <a:latin typeface="Arial" pitchFamily="34" charset="0"/>
                 <a:cs typeface="Arial" pitchFamily="34" charset="0"/>
               </a:rPr>
-              <a:t>AI &amp; Hardware: </a:t>
+              <a:t>Open-Source Repository: </a:t>
+            </a:r>
+            <a:r>
+              <a:rPr lang="en-US" sz="1300" dirty="0">
+                <a:solidFill>
+                  <a:srgbClr val="1E293B"/>
+                </a:solidFill>
+                <a:latin typeface="Arial" pitchFamily="34" charset="0"/>
+                <a:cs typeface="Arial" pitchFamily="34" charset="0"/>
+              </a:rPr>
+              <a:t>https://github.com/Sachin7-kumar/satya-id-screening</a:t>
+            </a:r>
+          </a:p>
+          <a:p>
+            <a:pPr marL="550000" indent="-200000" algn="l">
+              <a:lnSpc>
+                <a:spcPct val="118000"/>
+              </a:lnSpc>
+              <a:spcBef>
+                <a:spcPts val="55"/>
+              </a:spcBef>
+              <a:spcAft>
+                <a:spcPts val="35"/>
+              </a:spcAft>
+              <a:buFont typeface="Arial" pitchFamily="34" charset="0"/>
+              <a:buChar char="–"/>
+            </a:pPr>
+            <a:r>
+              <a:rPr lang="en-US" sz="1300" b="1" dirty="0">
+                <a:solidFill>
+                  <a:srgbClr val="0070C0"/>
+                </a:solidFill>
+                <a:latin typeface="Arial" pitchFamily="34" charset="0"/>
+                <a:cs typeface="Arial" pitchFamily="34" charset="0"/>
+              </a:rPr>
+              <a:t>AI &amp; Hardware Specs: </a:t>
             </a:r>
             <a:r>
               <a:rPr lang="en-US" sz="1300" dirty="0">
@@ -7233,7 +7348,7 @@
                 <a:latin typeface="Arial" pitchFamily="34" charset="0"/>
                 <a:cs typeface="Arial" pitchFamily="34" charset="0"/>
               </a:rPr>
-              <a:t>RAM Ingestion ➔ Math Checksums ➔ ELA ➔ Metrology/AI ➔ Sec 63 BSA</a:t>
+              <a:t>RAM Ingest ➔ Checksums (&lt;5ms) ➔ ELA Physics ➔ Metrology/Morph ➔ Sec 63 BSA</a:t>
             </a:r>
           </a:p>
           <a:p>
@@ -7268,7 +7383,7 @@
                 <a:latin typeface="Arial" pitchFamily="34" charset="0"/>
                 <a:cs typeface="Arial" pitchFamily="34" charset="0"/>
               </a:rPr>
-              <a:t>100% Offline Autonomy | 18–34ms Latency | 1,620 Docs/Min</a:t>
+              <a:t>18–34ms Latency | 1,620 Docs/Min | 100% Offline Edge Autonomy</a:t>
             </a:r>
           </a:p>
         </p:txBody>
@@ -7772,7 +7887,7 @@
                 <a:latin typeface="Arial" pitchFamily="34" charset="0"/>
                 <a:cs typeface="Arial" pitchFamily="34" charset="0"/>
               </a:rPr>
-              <a:t>GenAI Inpainting: </a:t>
+              <a:t>GenAI Inpainting Risk: </a:t>
             </a:r>
             <a:r>
               <a:rPr lang="en-US" sz="1250" dirty="0">
@@ -7782,7 +7897,7 @@
                 <a:latin typeface="Arial" pitchFamily="34" charset="0"/>
                 <a:cs typeface="Arial" pitchFamily="34" charset="0"/>
               </a:rPr>
-              <a:t>Diffusion Synthesis Without Pixel Boundaries</a:t>
+              <a:t>Diffusion synthesis generates realistic text without pixel seams</a:t>
             </a:r>
           </a:p>
           <a:p>
@@ -9205,10 +9320,10 @@
                 <a:spcPct val="118000"/>
               </a:lnSpc>
               <a:spcBef>
-                <a:spcPts val="40"/>
+                <a:spcPts val="38"/>
               </a:spcBef>
               <a:spcAft>
-                <a:spcPts val="20"/>
+                <a:spcPts val="18"/>
               </a:spcAft>
               <a:buFont typeface="Arial" pitchFamily="34" charset="0"/>
               <a:buChar char="–"/>
@@ -9231,7 +9346,7 @@
                 <a:latin typeface="Arial" pitchFamily="34" charset="0"/>
                 <a:cs typeface="Arial" pitchFamily="34" charset="0"/>
               </a:rPr>
-              <a:t>65,893 Cases (71.2% Document Forgery Rate)</a:t>
+              <a:t>65,893 Cases (71.2% Document Forgery Rate) – ncrb.gov.in</a:t>
             </a:r>
           </a:p>
           <a:p>
@@ -9240,10 +9355,10 @@
                 <a:spcPct val="118000"/>
               </a:lnSpc>
               <a:spcBef>
-                <a:spcPts val="40"/>
+                <a:spcPts val="38"/>
               </a:spcBef>
               <a:spcAft>
-                <a:spcPts val="20"/>
+                <a:spcPts val="18"/>
               </a:spcAft>
               <a:buFont typeface="Arial" pitchFamily="34" charset="0"/>
               <a:buChar char="–"/>
@@ -9266,7 +9381,7 @@
                 <a:latin typeface="Arial" pitchFamily="34" charset="0"/>
                 <a:cs typeface="Arial" pitchFamily="34" charset="0"/>
               </a:rPr>
-              <a:t>67.2 Lakh Fraudulent Ghost SIM Cards Blocked</a:t>
+              <a:t>67.2 Lakh Fraudulent Ghost SIM Cards Blocked – sancharsaathi.gov.in</a:t>
             </a:r>
           </a:p>
           <a:p>
@@ -9275,10 +9390,10 @@
                 <a:spcPct val="118000"/>
               </a:lnSpc>
               <a:spcBef>
-                <a:spcPts val="40"/>
+                <a:spcPts val="38"/>
               </a:spcBef>
               <a:spcAft>
-                <a:spcPts val="20"/>
+                <a:spcPts val="18"/>
               </a:spcAft>
               <a:buFont typeface="Arial" pitchFamily="34" charset="0"/>
               <a:buChar char="–"/>
@@ -9301,7 +9416,7 @@
                 <a:latin typeface="Arial" pitchFamily="34" charset="0"/>
                 <a:cs typeface="Arial" pitchFamily="34" charset="0"/>
               </a:rPr>
-              <a:t>Digital Image Error Level Analysis (ELA) Standards</a:t>
+              <a:t>Digital Image Error Level Analysis (ELA) Forensic Standards</a:t>
             </a:r>
           </a:p>
           <a:p>
@@ -9310,10 +9425,10 @@
                 <a:spcPct val="118000"/>
               </a:lnSpc>
               <a:spcBef>
-                <a:spcPts val="40"/>
+                <a:spcPts val="38"/>
               </a:spcBef>
               <a:spcAft>
-                <a:spcPts val="20"/>
+                <a:spcPts val="18"/>
               </a:spcAft>
               <a:buFont typeface="Arial" pitchFamily="34" charset="0"/>
               <a:buChar char="–"/>
@@ -9336,7 +9451,7 @@
                 <a:latin typeface="Arial" pitchFamily="34" charset="0"/>
                 <a:cs typeface="Arial" pitchFamily="34" charset="0"/>
               </a:rPr>
-              <a:t>Verhoeff Dihedral Group D5 Checksum</a:t>
+              <a:t>Verhoeff Dihedral Group D5 Checksum Algorithm</a:t>
             </a:r>
           </a:p>
           <a:p>
@@ -9345,10 +9460,10 @@
                 <a:spcPct val="118000"/>
               </a:lnSpc>
               <a:spcBef>
-                <a:spcPts val="40"/>
+                <a:spcPts val="38"/>
               </a:spcBef>
               <a:spcAft>
-                <a:spcPts val="20"/>
+                <a:spcPts val="18"/>
               </a:spcAft>
               <a:buFont typeface="Arial" pitchFamily="34" charset="0"/>
               <a:buChar char="–"/>
@@ -9371,7 +9486,7 @@
                 <a:latin typeface="Arial" pitchFamily="34" charset="0"/>
                 <a:cs typeface="Arial" pitchFamily="34" charset="0"/>
               </a:rPr>
-              <a:t>Section 63 Evidence Admissibility</a:t>
+              <a:t>Section 63 Evidence Admissibility (replacing Sec 65B)</a:t>
             </a:r>
           </a:p>
           <a:p>
@@ -9380,10 +9495,10 @@
                 <a:spcPct val="118000"/>
               </a:lnSpc>
               <a:spcBef>
-                <a:spcPts val="40"/>
+                <a:spcPts val="38"/>
               </a:spcBef>
               <a:spcAft>
-                <a:spcPts val="20"/>
+                <a:spcPts val="18"/>
               </a:spcAft>
               <a:buFont typeface="Arial" pitchFamily="34" charset="0"/>
               <a:buChar char="–"/>
@@ -9406,7 +9521,7 @@
                 <a:latin typeface="Arial" pitchFamily="34" charset="0"/>
                 <a:cs typeface="Arial" pitchFamily="34" charset="0"/>
               </a:rPr>
-              <a:t>Face Morphing Attack Detection Standards</a:t>
+              <a:t>Face Morphing Attack Detection Standards in Border E-Gates</a:t>
             </a:r>
           </a:p>
           <a:p>
@@ -9415,10 +9530,10 @@
                 <a:spcPct val="118000"/>
               </a:lnSpc>
               <a:spcBef>
-                <a:spcPts val="40"/>
+                <a:spcPts val="38"/>
               </a:spcBef>
               <a:spcAft>
-                <a:spcPts val="20"/>
+                <a:spcPts val="18"/>
               </a:spcAft>
               <a:buFont typeface="Arial" pitchFamily="34" charset="0"/>
               <a:buChar char="–"/>
@@ -9431,7 +9546,7 @@
                 <a:latin typeface="Arial" pitchFamily="34" charset="0"/>
                 <a:cs typeface="Arial" pitchFamily="34" charset="0"/>
               </a:rPr>
-              <a:t>[7] TransUnion CIBIL &amp; RBI Study: </a:t>
+              <a:t>[7] DPDP Act 2023 (Section 8): </a:t>
             </a:r>
             <a:r>
               <a:rPr lang="en-US" sz="1200" dirty="0">
@@ -9441,7 +9556,7 @@
                 <a:latin typeface="Arial" pitchFamily="34" charset="0"/>
                 <a:cs typeface="Arial" pitchFamily="34" charset="0"/>
               </a:rPr>
-              <a:t>Synthetic ID Fraud in Retail Lending</a:t>
+              <a:t>Statutory Mandate: Zero Citizen ID Retention in Memory</a:t>
             </a:r>
           </a:p>
           <a:p>
@@ -9450,10 +9565,10 @@
                 <a:spcPct val="118000"/>
               </a:lnSpc>
               <a:spcBef>
-                <a:spcPts val="40"/>
+                <a:spcPts val="38"/>
               </a:spcBef>
               <a:spcAft>
-                <a:spcPts val="20"/>
+                <a:spcPts val="18"/>
               </a:spcAft>
               <a:buFont typeface="Arial" pitchFamily="34" charset="0"/>
               <a:buChar char="–"/>
@@ -9466,7 +9581,7 @@
                 <a:latin typeface="Arial" pitchFamily="34" charset="0"/>
                 <a:cs typeface="Arial" pitchFamily="34" charset="0"/>
               </a:rPr>
-              <a:t>[8] DPDP Act 2023 (Section 8): </a:t>
+              <a:t>[8] Live Vercel Production: </a:t>
             </a:r>
             <a:r>
               <a:rPr lang="en-US" sz="1200" dirty="0">
@@ -9476,7 +9591,42 @@
                 <a:latin typeface="Arial" pitchFamily="34" charset="0"/>
                 <a:cs typeface="Arial" pitchFamily="34" charset="0"/>
               </a:rPr>
-              <a:t>Zero Citizen ID Retention Memory Mandate</a:t>
+              <a:t>https://satya-id-screening.vercel.app</a:t>
+            </a:r>
+          </a:p>
+          <a:p>
+            <a:pPr marL="550000" indent="-200000" algn="l">
+              <a:lnSpc>
+                <a:spcPct val="118000"/>
+              </a:lnSpc>
+              <a:spcBef>
+                <a:spcPts val="38"/>
+              </a:spcBef>
+              <a:spcAft>
+                <a:spcPts val="18"/>
+              </a:spcAft>
+              <a:buFont typeface="Arial" pitchFamily="34" charset="0"/>
+              <a:buChar char="–"/>
+            </a:pPr>
+            <a:r>
+              <a:rPr lang="en-US" sz="1200" b="1" dirty="0">
+                <a:solidFill>
+                  <a:srgbClr val="0070C0"/>
+                </a:solidFill>
+                <a:latin typeface="Arial" pitchFamily="34" charset="0"/>
+                <a:cs typeface="Arial" pitchFamily="34" charset="0"/>
+              </a:rPr>
+              <a:t>[9] GitHub Open Source Repo: </a:t>
+            </a:r>
+            <a:r>
+              <a:rPr lang="en-US" sz="1200" dirty="0">
+                <a:solidFill>
+                  <a:srgbClr val="1E293B"/>
+                </a:solidFill>
+                <a:latin typeface="Arial" pitchFamily="34" charset="0"/>
+                <a:cs typeface="Arial" pitchFamily="34" charset="0"/>
+              </a:rPr>
+              <a:t>https://github.com/Sachin7-kumar/satya-id-screening</a:t>
             </a:r>
           </a:p>
         </p:txBody>
@@ -9948,7 +10098,7 @@
                 <a:latin typeface="Arial" pitchFamily="34" charset="0"/>
                 <a:cs typeface="Arial" pitchFamily="34" charset="0"/>
               </a:rPr>
-              <a:t>Interactive Prototype Modules (Live at D:\react\satya-id-screening)</a:t>
+              <a:t>Operational Software Deployment &amp; Live Links</a:t>
             </a:r>
           </a:p>
           <a:p>
@@ -9973,7 +10123,7 @@
                 <a:latin typeface="Arial" pitchFamily="34" charset="0"/>
                 <a:cs typeface="Arial" pitchFamily="34" charset="0"/>
               </a:rPr>
-              <a:t>Multi-Spectral ELA Visualizer: </a:t>
+              <a:t>Live Production URL: </a:t>
             </a:r>
             <a:r>
               <a:rPr lang="en-US" sz="1300" dirty="0">
@@ -9983,7 +10133,7 @@
                 <a:latin typeface="Arial" pitchFamily="34" charset="0"/>
                 <a:cs typeface="Arial" pitchFamily="34" charset="0"/>
               </a:rPr>
-              <a:t>Real-Time Differencing with 10x–45x Gain</a:t>
+              <a:t>https://satya-id-screening.vercel.app (Status: 200 OK | SSL Secure)</a:t>
             </a:r>
           </a:p>
           <a:p>
@@ -10008,7 +10158,7 @@
                 <a:latin typeface="Arial" pitchFamily="34" charset="0"/>
                 <a:cs typeface="Arial" pitchFamily="34" charset="0"/>
               </a:rPr>
-              <a:t>3D Strata Exploder: </a:t>
+              <a:t>Open Source Codebase: </a:t>
             </a:r>
             <a:r>
               <a:rPr lang="en-US" sz="1300" dirty="0">
@@ -10018,7 +10168,7 @@
                 <a:latin typeface="Arial" pitchFamily="34" charset="0"/>
                 <a:cs typeface="Arial" pitchFamily="34" charset="0"/>
               </a:rPr>
-              <a:t>Interactive Surface &amp; Baseline Decomposition</a:t>
+              <a:t>https://github.com/Sachin7-kumar/satya-id-screening (Full Stack)</a:t>
             </a:r>
           </a:p>
           <a:p>
@@ -10043,7 +10193,7 @@
                 <a:latin typeface="Arial" pitchFamily="34" charset="0"/>
                 <a:cs typeface="Arial" pitchFamily="34" charset="0"/>
               </a:rPr>
-              <a:t>Algorithmic Invariants Engine: </a:t>
+              <a:t>Live Serverless APIs: </a:t>
             </a:r>
             <a:r>
               <a:rPr lang="en-US" sz="1300" dirty="0">
@@ -10053,7 +10203,32 @@
                 <a:latin typeface="Arial" pitchFamily="34" charset="0"/>
                 <a:cs typeface="Arial" pitchFamily="34" charset="0"/>
               </a:rPr>
-              <a:t>Verhoeff D5, PAN Regex &amp; MRZ Checks (&lt;5ms)</a:t>
+              <a:t>/api/scan | /api/threat-intel | /api/system-status | /api/generate-cert</a:t>
+            </a:r>
+          </a:p>
+          <a:p>
+            <a:pPr marL="342900" indent="-342900" algn="l">
+              <a:lnSpc>
+                <a:spcPct val="120000"/>
+              </a:lnSpc>
+              <a:spcBef>
+                <a:spcPts val="140"/>
+              </a:spcBef>
+              <a:spcAft>
+                <a:spcPts val="45"/>
+              </a:spcAft>
+              <a:buFont typeface="Arial" pitchFamily="34" charset="0"/>
+              <a:buChar char="•"/>
+            </a:pPr>
+            <a:r>
+              <a:rPr lang="en-US" sz="1400" b="1" dirty="0">
+                <a:solidFill>
+                  <a:srgbClr val="0F172A"/>
+                </a:solidFill>
+                <a:latin typeface="Arial" pitchFamily="34" charset="0"/>
+                <a:cs typeface="Arial" pitchFamily="34" charset="0"/>
+              </a:rPr>
+              <a:t>Interactive Prototype Modules &amp; Forensic HUD</a:t>
             </a:r>
           </a:p>
           <a:p>
@@ -10078,7 +10253,7 @@
                 <a:latin typeface="Arial" pitchFamily="34" charset="0"/>
                 <a:cs typeface="Arial" pitchFamily="34" charset="0"/>
               </a:rPr>
-              <a:t>Gemini Multimodal AI Copilot: </a:t>
+              <a:t>Multi-Spectral ELA Visualizer: </a:t>
             </a:r>
             <a:r>
               <a:rPr lang="en-US" sz="1300" dirty="0">
@@ -10088,7 +10263,112 @@
                 <a:latin typeface="Arial" pitchFamily="34" charset="0"/>
                 <a:cs typeface="Arial" pitchFamily="34" charset="0"/>
               </a:rPr>
-              <a:t>Contextual Anomaly Inquest via Gemini Flash</a:t>
+              <a:t>Real-time Q=92% differencing with dynamic 10x–45x delta gain</a:t>
+            </a:r>
+          </a:p>
+          <a:p>
+            <a:pPr marL="550000" indent="-200000" algn="l">
+              <a:lnSpc>
+                <a:spcPct val="118000"/>
+              </a:lnSpc>
+              <a:spcBef>
+                <a:spcPts val="55"/>
+              </a:spcBef>
+              <a:spcAft>
+                <a:spcPts val="35"/>
+              </a:spcAft>
+              <a:buFont typeface="Arial" pitchFamily="34" charset="0"/>
+              <a:buChar char="–"/>
+            </a:pPr>
+            <a:r>
+              <a:rPr lang="en-US" sz="1300" b="1" dirty="0">
+                <a:solidFill>
+                  <a:srgbClr val="0070C0"/>
+                </a:solidFill>
+                <a:latin typeface="Arial" pitchFamily="34" charset="0"/>
+                <a:cs typeface="Arial" pitchFamily="34" charset="0"/>
+              </a:rPr>
+              <a:t>3D Strata Exploder: </a:t>
+            </a:r>
+            <a:r>
+              <a:rPr lang="en-US" sz="1300" dirty="0">
+                <a:solidFill>
+                  <a:srgbClr val="1E293B"/>
+                </a:solidFill>
+                <a:latin typeface="Arial" pitchFamily="34" charset="0"/>
+                <a:cs typeface="Arial" pitchFamily="34" charset="0"/>
+              </a:rPr>
+              <a:t>Interactive separation of surface substrate, ink &amp; digital overlays</a:t>
+            </a:r>
+          </a:p>
+          <a:p>
+            <a:pPr marL="550000" indent="-200000" algn="l">
+              <a:lnSpc>
+                <a:spcPct val="118000"/>
+              </a:lnSpc>
+              <a:spcBef>
+                <a:spcPts val="55"/>
+              </a:spcBef>
+              <a:spcAft>
+                <a:spcPts val="35"/>
+              </a:spcAft>
+              <a:buFont typeface="Arial" pitchFamily="34" charset="0"/>
+              <a:buChar char="–"/>
+            </a:pPr>
+            <a:r>
+              <a:rPr lang="en-US" sz="1300" b="1" dirty="0">
+                <a:solidFill>
+                  <a:srgbClr val="0070C0"/>
+                </a:solidFill>
+                <a:latin typeface="Arial" pitchFamily="34" charset="0"/>
+                <a:cs typeface="Arial" pitchFamily="34" charset="0"/>
+              </a:rPr>
+              <a:t>Algorithmic Invariants Engine: </a:t>
+            </a:r>
+            <a:r>
+              <a:rPr lang="en-US" sz="1300" dirty="0">
+                <a:solidFill>
+                  <a:srgbClr val="1E293B"/>
+                </a:solidFill>
+                <a:latin typeface="Arial" pitchFamily="34" charset="0"/>
+                <a:cs typeface="Arial" pitchFamily="34" charset="0"/>
+              </a:rPr>
+              <a:t>Verhoeff D5, PAN regex, and MRZ 7-3-1 checks (&lt;5ms)</a:t>
+            </a:r>
+          </a:p>
+          <a:p>
+            <a:pPr marL="550000" indent="-200000" algn="l">
+              <a:lnSpc>
+                <a:spcPct val="118000"/>
+              </a:lnSpc>
+              <a:spcBef>
+                <a:spcPts val="55"/>
+              </a:spcBef>
+              <a:spcAft>
+                <a:spcPts val="35"/>
+              </a:spcAft>
+              <a:buFont typeface="Arial" pitchFamily="34" charset="0"/>
+              <a:buChar char="–"/>
+            </a:pPr>
+            <a:r>
+              <a:rPr lang="en-US" sz="1300" b="1" dirty="0">
+                <a:solidFill>
+                  <a:srgbClr val="0070C0"/>
+                </a:solidFill>
+                <a:latin typeface="Arial" pitchFamily="34" charset="0"/>
+                <a:cs typeface="Arial" pitchFamily="34" charset="0"/>
+              </a:rPr>
+              <a:t>Gemini Multimodal AI Copilot: </a:t>
+            </a:r>
+            <a:r>
+              <a:rPr lang="en-US" sz="1300" dirty="0">
+                <a:solidFill>
+                  <a:srgbClr val="1E293B"/>
+                </a:solidFill>
+                <a:latin typeface="Arial" pitchFamily="34" charset="0"/>
+                <a:cs typeface="Arial" pitchFamily="34" charset="0"/>
+              </a:rPr>
+              <a:t>Contextual semantic anomaly reasoning via Gemini Flash</a:t>
             </a:r>
           </a:p>
           <a:p>
@@ -10148,32 +10428,7 @@
                 <a:latin typeface="Arial" pitchFamily="34" charset="0"/>
                 <a:cs typeface="Arial" pitchFamily="34" charset="0"/>
               </a:rPr>
-              <a:t>Instant Legal Export with Verifiable SHA-256 Seal</a:t>
-            </a:r>
-          </a:p>
-          <a:p>
-            <a:pPr marL="342900" indent="-342900" algn="l">
-              <a:lnSpc>
-                <a:spcPct val="120000"/>
-              </a:lnSpc>
-              <a:spcBef>
-                <a:spcPts val="140"/>
-              </a:spcBef>
-              <a:spcAft>
-                <a:spcPts val="45"/>
-              </a:spcAft>
-              <a:buFont typeface="Arial" pitchFamily="34" charset="0"/>
-              <a:buChar char="•"/>
-            </a:pPr>
-            <a:r>
-              <a:rPr lang="en-US" sz="1400" b="1" dirty="0">
-                <a:solidFill>
-                  <a:srgbClr val="0F172A"/>
-                </a:solidFill>
-                <a:latin typeface="Arial" pitchFamily="34" charset="0"/>
-                <a:cs typeface="Arial" pitchFamily="34" charset="0"/>
-              </a:rPr>
-              <a:t>Live Prototype Test Cases &amp; Ground Benchmarks</a:t>
+              <a:t>Instant legal export with SHA-256 seal &amp; hardware telemetry</a:t>
             </a:r>
           </a:p>
           <a:p>
@@ -10198,7 +10453,7 @@
                 <a:latin typeface="Arial" pitchFamily="34" charset="0"/>
                 <a:cs typeface="Arial" pitchFamily="34" charset="0"/>
               </a:rPr>
-              <a:t>Demonstrated Test Suites: </a:t>
+              <a:t>Validated Edge Benchmarks: </a:t>
             </a:r>
             <a:r>
               <a:rPr lang="en-US" sz="1300" dirty="0">
@@ -10208,42 +10463,7 @@
                 <a:latin typeface="Arial" pitchFamily="34" charset="0"/>
                 <a:cs typeface="Arial" pitchFamily="34" charset="0"/>
               </a:rPr>
-              <a:t>Aadhaar (22ms) | PAN DOB (19ms) | Passport MRZ (4ms)</a:t>
-            </a:r>
-          </a:p>
-          <a:p>
-            <a:pPr marL="550000" indent="-200000" algn="l">
-              <a:lnSpc>
-                <a:spcPct val="118000"/>
-              </a:lnSpc>
-              <a:spcBef>
-                <a:spcPts val="55"/>
-              </a:spcBef>
-              <a:spcAft>
-                <a:spcPts val="35"/>
-              </a:spcAft>
-              <a:buFont typeface="Arial" pitchFamily="34" charset="0"/>
-              <a:buChar char="–"/>
-            </a:pPr>
-            <a:r>
-              <a:rPr lang="en-US" sz="1300" b="1" dirty="0">
-                <a:solidFill>
-                  <a:srgbClr val="0070C0"/>
-                </a:solidFill>
-                <a:latin typeface="Arial" pitchFamily="34" charset="0"/>
-                <a:cs typeface="Arial" pitchFamily="34" charset="0"/>
-              </a:rPr>
-              <a:t>Edge Performance Benchmarks: </a:t>
-            </a:r>
-            <a:r>
-              <a:rPr lang="en-US" sz="1300" dirty="0">
-                <a:solidFill>
-                  <a:srgbClr val="1E293B"/>
-                </a:solidFill>
-                <a:latin typeface="Arial" pitchFamily="34" charset="0"/>
-                <a:cs typeface="Arial" pitchFamily="34" charset="0"/>
-              </a:rPr>
-              <a:t>18–34ms Latency | 1,620 Docs/Min | 100% Offline Edge</a:t>
+              <a:t>18–34ms Latency | 1,620 Docs/Min | &lt;0.18% FPR | 100% Offline Edge</a:t>
             </a:r>
           </a:p>
         </p:txBody>

</xml_diff>